<commit_message>
Remove comentário órfão do arquivo com os slides alterados
Co-Authored-By: Claude Opus 5.5 <noreply@anthropic.com>
Claude-Session: https://claude.ai/code/session_01BauMyZR5unRwjRYRzKjEpf
</commit_message>
<xml_diff>
--- a/metodologia_cidades_inteligentes/apresentacao/Slides_alterados_CSE_na_media.pptx
+++ b/metodologia_cidades_inteligentes/apresentacao/Slides_alterados_CSE_na_media.pptx
@@ -127,29 +127,6 @@
     <p1510:client id="{FC98BB44-32F3-4A47-BF4A-DC2A4714ACFF}" v="301" dt="2026-10-14T16:29:13.410"/>
   </p1510:revLst>
 </p1510:revInfo>
-</file>
-
-<file path=ppt/comments/modernComment_114_0.xml><?xml version="1.0" encoding="utf-8"?>
-<p188:cmLst xmlns:a="http://schemas.openxmlformats.org/drawingml/2006/main" xmlns:r="http://schemas.openxmlformats.org/officeDocument/2006/relationships" xmlns:p188="http://schemas.microsoft.com/office/powerpoint/2018/8/main">
-  <p188:cm id="{4E27D9C2-6A37-474C-99D8-FC0771B516B8}" authorId="{70D6D7DC-4737-C906-77DC-4E59050D7ABE}" created="2026-10-15T09:26:17.091">
-    <ac:deMkLst xmlns:ac="http://schemas.microsoft.com/office/drawing/2013/main/command">
-      <pc:docMk xmlns:pc="http://schemas.microsoft.com/office/powerpoint/2013/main/command"/>
-      <pc:sldMk xmlns:pc="http://schemas.microsoft.com/office/powerpoint/2013/main/command" cId="0" sldId="276"/>
-      <ac:graphicFrameMk id="12" creationId="{00000000-0000-0000-0000-000000000000}"/>
-    </ac:deMkLst>
-    <p188:txBody>
-      <a:bodyPr/>
-      <a:lstStyle/>
-      <a:p>
-        <a:r>
-          <a:rPr lang="pt-BR"/>
-          <a:t>Para que não ficasse CIF (Capacidade institucional e fiscal), alterei para CFI (Capacidade fiscal e institucional). 
-- Apenas não consegui alterar no gráfico. </a:t>
-        </a:r>
-      </a:p>
-    </p188:txBody>
-  </p188:cm>
-</p188:cmLst>
 </file>
 
 <file path=ppt/notesMasters/notesMaster1.xml><?xml version="1.0" encoding="utf-8"?>

</xml_diff>